<commit_message>
Fixed website to ensure memory under 1GB to run on render
</commit_message>
<xml_diff>
--- a/VUS_Results_final_updated.pptx
+++ b/VUS_Results_final_updated.pptx
@@ -34,6 +34,7 @@
     <p:sldId id="282" r:id="rId29"/>
     <p:sldId id="283" r:id="rId30"/>
     <p:sldId id="284" r:id="rId31"/>
+    <p:sldId id="286" r:id="rId34"/>
     <p:sldId id="285" r:id="rId32"/>
   </p:sldIdLst>
   <p:sldSz cx="12192000" cy="6858000"/>
@@ -22177,6 +22178,582 @@
 </file>
 
 <file path=ppt/slides/slide30.xml><?xml version="1.0" encoding="utf-8"?>
+<p:sld xmlns:a="http://schemas.openxmlformats.org/drawingml/2006/main" xmlns:p="http://schemas.openxmlformats.org/presentationml/2006/main" xmlns:r="http://schemas.openxmlformats.org/officeDocument/2006/relationships" xmlns:p14="http://schemas.microsoft.com/office/powerpoint/2010/main" xmlns:p15="http://schemas.microsoft.com/office/powerpoint/2012/main" xmlns:mc="http://schemas.openxmlformats.org/markup-compatibility/2006">
+  <p:cSld>
+    <p:bg>
+      <p:bgPr>
+        <a:solidFill>
+          <a:srgbClr val="1F242E"/>
+        </a:solidFill>
+      </p:bgPr>
+    </p:bg>
+    <p:spTree>
+      <p:nvGrpSpPr>
+        <p:cNvPr id="1" name=""/>
+        <p:cNvGrpSpPr/>
+        <p:nvPr/>
+      </p:nvGrpSpPr>
+      <p:grpSpPr>
+        <a:xfrm>
+          <a:off x="0" y="0"/>
+          <a:ext cx="0" cy="0"/>
+          <a:chOff x="0" y="0"/>
+          <a:chExt cx="0" cy="0"/>
+        </a:xfrm>
+      </p:grpSpPr>
+      <p:sp>
+        <p:nvSpPr>
+          <p:cNvPr id="337" name=""/>
+          <p:cNvSpPr txBox="1"/>
+          <p:nvPr/>
+        </p:nvSpPr>
+        <p:spPr>
+          <a:xfrm>
+            <a:off x="548640" y="502920"/>
+            <a:ext cx="7315200" cy="365760"/>
+          </a:xfrm>
+          <a:prstGeom prst="rect">
+            <a:avLst/>
+          </a:prstGeom>
+          <a:noFill/>
+          <a:ln w="0">
+            <a:noFill/>
+          </a:ln>
+        </p:spPr>
+        <p:txBody>
+          <a:bodyPr lIns="90000" tIns="45000" rIns="90000" bIns="45000" anchor="t">
+            <a:spAutoFit/>
+          </a:bodyPr>
+          <a:p>
+            <a:r>
+              <a:rPr lang="en-US" sz="1300" b="1" u="none" spc="201" strike="noStrike">
+                <a:solidFill>
+                  <a:srgbClr val="E9C467"/>
+                </a:solidFill>
+                <a:effectLst/>
+                <a:uFillTx/>
+                <a:latin typeface="Calibri-Bold"/>
+                <a:ea typeface="Calibri-Bold"/>
+              </a:rPr>
+              <a:t>LIVE DEMO</a:t>
+            </a:r>
+            <a:endParaRPr lang="en-US" sz="1300" b="0" u="none" strike="noStrike">
+              <a:solidFill>
+                <a:srgbClr val="FFFFFF"/>
+              </a:solidFill>
+              <a:effectLst/>
+              <a:uFillTx/>
+              <a:latin typeface="Arial"/>
+            </a:endParaRPr>
+          </a:p>
+        </p:txBody>
+      </p:sp>
+      <p:sp>
+        <p:nvSpPr>
+          <p:cNvPr id="338" name=""/>
+          <p:cNvSpPr txBox="1"/>
+          <p:nvPr/>
+        </p:nvSpPr>
+        <p:spPr>
+          <a:xfrm>
+            <a:off x="548640" y="868680"/>
+            <a:ext cx="11064240" cy="914400"/>
+          </a:xfrm>
+          <a:prstGeom prst="rect">
+            <a:avLst/>
+          </a:prstGeom>
+          <a:noFill/>
+          <a:ln w="0">
+            <a:noFill/>
+          </a:ln>
+        </p:spPr>
+        <p:txBody>
+          <a:bodyPr lIns="90000" tIns="45000" rIns="90000" bIns="45000" anchor="t">
+            <a:spAutoFit/>
+          </a:bodyPr>
+          <a:p>
+            <a:pPr>
+              <a:lnSpc>
+                <a:spcPct val="105000"/>
+              </a:lnSpc>
+            </a:pPr>
+            <a:r>
+              <a:rPr lang="en-US" sz="3000" b="1" u="none" strike="noStrike">
+                <a:solidFill>
+                  <a:srgbClr val="FFFFFF"/>
+                </a:solidFill>
+                <a:effectLst/>
+                <a:uFillTx/>
+                <a:latin typeface="Cambria-Bold"/>
+                <a:ea typeface="Cambria-Bold"/>
+              </a:rPr>
+              <a:t>See the Model Run, Live</a:t>
+            </a:r>
+            <a:endParaRPr lang="en-US" sz="3000" b="0" u="none" strike="noStrike">
+              <a:solidFill>
+                <a:srgbClr val="FFFFFF"/>
+              </a:solidFill>
+              <a:effectLst/>
+              <a:uFillTx/>
+              <a:latin typeface="Arial"/>
+            </a:endParaRPr>
+          </a:p>
+        </p:txBody>
+      </p:sp>
+      <p:sp>
+        <p:nvSpPr>
+          <p:cNvPr id="339" name=""/>
+          <p:cNvSpPr txBox="1"/>
+          <p:nvPr/>
+        </p:nvSpPr>
+        <p:spPr>
+          <a:xfrm>
+            <a:off x="548640" y="1783080"/>
+            <a:ext cx="11064240" cy="640080"/>
+          </a:xfrm>
+          <a:prstGeom prst="rect">
+            <a:avLst/>
+          </a:prstGeom>
+          <a:noFill/>
+          <a:ln w="0">
+            <a:noFill/>
+          </a:ln>
+        </p:spPr>
+        <p:txBody>
+          <a:bodyPr lIns="90000" tIns="45000" rIns="90000" bIns="45000" anchor="t">
+            <a:spAutoFit/>
+          </a:bodyPr>
+          <a:p>
+            <a:pPr>
+              <a:lnSpc>
+                <a:spcPct val="135000"/>
+              </a:lnSpc>
+            </a:pPr>
+            <a:r>
+              <a:rPr lang="en-US" sz="1400" b="0" u="none" strike="noStrike">
+                <a:solidFill>
+                  <a:srgbClr val="D6DEEC"/>
+                </a:solidFill>
+                <a:effectLst/>
+                <a:uFillTx/>
+                <a:latin typeface="Calibri"/>
+                <a:ea typeface="Calibri"/>
+              </a:rPr>
+              <a:t>The full Stage 1 and Stage 2 pipeline is deployed as a working web app: upload a MAF or VCF file and get real predictions back from the actual trained models behind this deck, not a mockup.</a:t>
+            </a:r>
+            <a:r>
+              <a:rPr lang="en-US" sz="1400" b="0" u="none" strike="noStrike">
+                <a:solidFill>
+                  <a:srgbClr val="D6DEEC"/>
+                </a:solidFill>
+                <a:effectLst/>
+                <a:uFillTx/>
+                <a:latin typeface="Calibri"/>
+                <a:ea typeface="Calibri"/>
+              </a:rPr>
+              <a:t/>
+            </a:r>
+            <a:r>
+              <a:rPr lang="en-US" sz="1400" b="0" u="none" strike="noStrike">
+                <a:solidFill>
+                  <a:srgbClr val="D6DEEC"/>
+                </a:solidFill>
+                <a:effectLst/>
+                <a:uFillTx/>
+                <a:latin typeface="Calibri"/>
+                <a:ea typeface="Calibri"/>
+              </a:rPr>
+              <a:t/>
+            </a:r>
+            <a:r>
+              <a:rPr lang="en-US" sz="1400" b="0" u="none" strike="noStrike">
+                <a:solidFill>
+                  <a:srgbClr val="D6DEEC"/>
+                </a:solidFill>
+                <a:effectLst/>
+                <a:uFillTx/>
+                <a:latin typeface="Calibri"/>
+                <a:ea typeface="Calibri"/>
+              </a:rPr>
+              <a:t/>
+            </a:r>
+            <a:endParaRPr lang="en-US" sz="1400" b="0" u="none" strike="noStrike">
+              <a:solidFill>
+                <a:srgbClr val="FFFFFF"/>
+              </a:solidFill>
+              <a:effectLst/>
+              <a:uFillTx/>
+              <a:latin typeface="Arial"/>
+            </a:endParaRPr>
+          </a:p>
+        </p:txBody>
+      </p:sp>
+      <p:sp>
+        <p:nvSpPr>
+          <p:cNvPr id="351" name="Rounded Rectangle 350"/>
+          <p:cNvSpPr/>
+          <p:nvPr/>
+        </p:nvSpPr>
+        <p:spPr>
+          <a:xfrm>
+            <a:off x="548640" y="2606040"/>
+            <a:ext cx="11064240" cy="2454480"/>
+          </a:xfrm>
+          <a:prstGeom prst="roundRect">
+            <a:avLst>
+              <a:gd name="adj" fmla="val 2000"/>
+            </a:avLst>
+          </a:prstGeom>
+          <a:solidFill>
+            <a:srgbClr val="1C375C"/>
+          </a:solidFill>
+          <a:ln>
+            <a:noFill/>
+          </a:ln>
+          <a:effectLst/>
+        </p:spPr>
+        <p:style>
+          <a:lnRef idx="1">
+            <a:schemeClr val="accent1"/>
+          </a:lnRef>
+          <a:fillRef idx="3">
+            <a:schemeClr val="accent1"/>
+          </a:fillRef>
+          <a:effectRef idx="2">
+            <a:schemeClr val="accent1"/>
+          </a:effectRef>
+          <a:fontRef idx="minor">
+            <a:schemeClr val="lt1"/>
+          </a:fontRef>
+        </p:style>
+        <p:txBody>
+          <a:bodyPr rtlCol="0" anchor="ctr"/>
+          <a:lstStyle/>
+          <a:p>
+            <a:pPr algn="ctr"/>
+          </a:p>
+        </p:txBody>
+      </p:sp>
+      <p:sp>
+        <p:nvSpPr>
+          <p:cNvPr id="341" name=""/>
+          <p:cNvSpPr txBox="1"/>
+          <p:nvPr/>
+        </p:nvSpPr>
+        <p:spPr>
+          <a:xfrm>
+            <a:off x="868680" y="2880360"/>
+            <a:ext cx="5012080" cy="320040"/>
+          </a:xfrm>
+          <a:prstGeom prst="rect">
+            <a:avLst/>
+          </a:prstGeom>
+          <a:noFill/>
+          <a:ln w="0">
+            <a:noFill/>
+          </a:ln>
+        </p:spPr>
+        <p:txBody>
+          <a:bodyPr lIns="90000" tIns="45000" rIns="90000" bIns="45000" anchor="t">
+            <a:spAutoFit/>
+          </a:bodyPr>
+          <a:p>
+            <a:r>
+              <a:rPr lang="en-US" sz="1100" b="1" u="none" spc="150" strike="noStrike">
+                <a:solidFill>
+                  <a:srgbClr val="279D8F"/>
+                </a:solidFill>
+                <a:effectLst/>
+                <a:uFillTx/>
+                <a:latin typeface="Calibri-Bold"/>
+                <a:ea typeface="Calibri-Bold"/>
+              </a:rPr>
+              <a:t>WEB APP</a:t>
+            </a:r>
+            <a:endParaRPr lang="en-US" sz="1100" b="0" u="none" strike="noStrike">
+              <a:solidFill>
+                <a:srgbClr val="FFFFFF"/>
+              </a:solidFill>
+              <a:effectLst/>
+              <a:uFillTx/>
+              <a:latin typeface="Arial"/>
+            </a:endParaRPr>
+          </a:p>
+        </p:txBody>
+      </p:sp>
+      <p:sp>
+        <p:nvSpPr>
+          <p:cNvPr id="343" name=""/>
+          <p:cNvSpPr txBox="1"/>
+          <p:nvPr/>
+        </p:nvSpPr>
+        <p:spPr>
+          <a:xfrm>
+            <a:off x="868680" y="3246120"/>
+            <a:ext cx="5012080" cy="900000"/>
+          </a:xfrm>
+          <a:prstGeom prst="rect">
+            <a:avLst/>
+          </a:prstGeom>
+          <a:noFill/>
+          <a:ln w="0">
+            <a:noFill/>
+          </a:ln>
+        </p:spPr>
+        <p:txBody>
+          <a:bodyPr lIns="90000" tIns="45000" rIns="90000" bIns="45000" anchor="t">
+            <a:spAutoFit/>
+          </a:bodyPr>
+          <a:p>
+            <a:pPr>
+              <a:lnSpc>
+                <a:spcPct val="140000"/>
+              </a:lnSpc>
+            </a:pPr>
+            <a:r>
+              <a:rPr lang="en-US" sz="1300" b="0" u="none" strike="noStrike">
+                <a:solidFill>
+                  <a:srgbClr val="AEBEDD"/>
+                </a:solidFill>
+                <a:effectLst/>
+                <a:uFillTx/>
+                <a:latin typeface="Calibri"/>
+                <a:ea typeface="Calibri"/>
+              </a:rPr>
+              <a:t>Upload a MAF or VCF file and get real Stage 1 and Stage 2 predictions back, generated by the same trained models used throughout this deck.</a:t>
+            </a:r>
+            <a:endParaRPr lang="en-US" sz="1300" b="0" u="none" strike="noStrike">
+              <a:solidFill>
+                <a:srgbClr val="FFFFFF"/>
+              </a:solidFill>
+              <a:effectLst/>
+              <a:uFillTx/>
+              <a:latin typeface="Arial"/>
+            </a:endParaRPr>
+          </a:p>
+        </p:txBody>
+      </p:sp>
+      <p:sp>
+        <p:nvSpPr>
+          <p:cNvPr id="344" name=""/>
+          <p:cNvSpPr txBox="1"/>
+          <p:nvPr/>
+        </p:nvSpPr>
+        <p:spPr>
+          <a:xfrm>
+            <a:off x="868680" y="4420440"/>
+            <a:ext cx="10424160" cy="365760"/>
+          </a:xfrm>
+          <a:prstGeom prst="rect">
+            <a:avLst/>
+          </a:prstGeom>
+          <a:noFill/>
+          <a:ln w="0">
+            <a:noFill/>
+          </a:ln>
+        </p:spPr>
+        <p:txBody>
+          <a:bodyPr lIns="90000" tIns="45000" rIns="90000" bIns="45000" anchor="t">
+            <a:spAutoFit/>
+          </a:bodyPr>
+          <a:p>
+            <a:pPr algn="ctr"/>
+            <a:r>
+              <a:rPr lang="en-US" sz="1800" b="1" u="sng" strike="noStrike">
+                <a:solidFill>
+                  <a:srgbClr val="E9C467"/>
+                </a:solidFill>
+                <a:effectLst/>
+                <a:uFillTx/>
+                <a:latin typeface="Arial"/>
+                <a:hlinkClick r:id="rId2"/>
+              </a:rPr>
+              <a:t>Open the Live App</a:t>
+            </a:r>
+            <a:endParaRPr lang="en-US" sz="1800" b="0" u="none" strike="noStrike">
+              <a:solidFill>
+                <a:srgbClr val="FFFFFF"/>
+              </a:solidFill>
+              <a:effectLst/>
+              <a:uFillTx/>
+              <a:latin typeface="Arial"/>
+            </a:endParaRPr>
+          </a:p>
+        </p:txBody>
+      </p:sp>
+      <p:sp>
+        <p:nvSpPr>
+          <p:cNvPr id="346" name=""/>
+          <p:cNvSpPr txBox="1"/>
+          <p:nvPr/>
+        </p:nvSpPr>
+        <p:spPr>
+          <a:xfrm>
+            <a:off x="6280760" y="2880360"/>
+            <a:ext cx="5012080" cy="320040"/>
+          </a:xfrm>
+          <a:prstGeom prst="rect">
+            <a:avLst/>
+          </a:prstGeom>
+          <a:noFill/>
+          <a:ln w="0">
+            <a:noFill/>
+          </a:ln>
+        </p:spPr>
+        <p:txBody>
+          <a:bodyPr lIns="90000" tIns="45000" rIns="90000" bIns="45000" anchor="t">
+            <a:spAutoFit/>
+          </a:bodyPr>
+          <a:p>
+            <a:r>
+              <a:rPr lang="en-US" sz="1100" b="1" u="none" spc="150" strike="noStrike">
+                <a:solidFill>
+                  <a:srgbClr val="E76C4E"/>
+                </a:solidFill>
+                <a:effectLst/>
+                <a:uFillTx/>
+                <a:latin typeface="Calibri-Bold"/>
+                <a:ea typeface="Calibri-Bold"/>
+              </a:rPr>
+              <a:t>HOW IT WORKS</a:t>
+            </a:r>
+            <a:endParaRPr lang="en-US" sz="1100" b="0" u="none" strike="noStrike">
+              <a:solidFill>
+                <a:srgbClr val="FFFFFF"/>
+              </a:solidFill>
+              <a:effectLst/>
+              <a:uFillTx/>
+              <a:latin typeface="Arial"/>
+            </a:endParaRPr>
+          </a:p>
+        </p:txBody>
+      </p:sp>
+      <p:sp>
+        <p:nvSpPr>
+          <p:cNvPr id="348" name=""/>
+          <p:cNvSpPr txBox="1"/>
+          <p:nvPr/>
+        </p:nvSpPr>
+        <p:spPr>
+          <a:xfrm>
+            <a:off x="6280760" y="3246120"/>
+            <a:ext cx="5012080" cy="900000"/>
+          </a:xfrm>
+          <a:prstGeom prst="rect">
+            <a:avLst/>
+          </a:prstGeom>
+          <a:noFill/>
+          <a:ln w="0">
+            <a:noFill/>
+          </a:ln>
+        </p:spPr>
+        <p:txBody>
+          <a:bodyPr lIns="90000" tIns="45000" rIns="90000" bIns="45000" anchor="t">
+            <a:spAutoFit/>
+          </a:bodyPr>
+          <a:p>
+            <a:pPr>
+              <a:lnSpc>
+                <a:spcPct val="140000"/>
+              </a:lnSpc>
+            </a:pPr>
+            <a:r>
+              <a:rPr lang="en-US" sz="1300" b="0" u="none" strike="noStrike">
+                <a:solidFill>
+                  <a:srgbClr val="AEBEDD"/>
+                </a:solidFill>
+                <a:effectLst/>
+                <a:uFillTx/>
+                <a:latin typeface="Calibri"/>
+                <a:ea typeface="Calibri"/>
+              </a:rPr>
+              <a:t>Each variant is sorted into germline, somatic, or VUS. Every VUS is then scored for reclassification probability, expected timing, and predicted direction.</a:t>
+            </a:r>
+            <a:endParaRPr lang="en-US" sz="1300" b="0" u="none" strike="noStrike">
+              <a:solidFill>
+                <a:srgbClr val="FFFFFF"/>
+              </a:solidFill>
+              <a:effectLst/>
+              <a:uFillTx/>
+              <a:latin typeface="Arial"/>
+            </a:endParaRPr>
+          </a:p>
+        </p:txBody>
+      </p:sp>
+      <p:sp>
+        <p:nvSpPr>
+          <p:cNvPr id="350" name=""/>
+          <p:cNvSpPr txBox="1"/>
+          <p:nvPr/>
+        </p:nvSpPr>
+        <p:spPr>
+          <a:xfrm>
+            <a:off x="11368840" y="6469560"/>
+            <a:ext cx="500000" cy="300000"/>
+          </a:xfrm>
+          <a:prstGeom prst="rect">
+            <a:avLst/>
+          </a:prstGeom>
+          <a:noFill/>
+          <a:ln w="0">
+            <a:noFill/>
+          </a:ln>
+        </p:spPr>
+        <p:txBody>
+          <a:bodyPr lIns="90000" tIns="45000" rIns="90000" bIns="45000" anchor="t">
+            <a:spAutoFit/>
+          </a:bodyPr>
+          <a:p>
+            <a:pPr algn="r"/>
+            <a:r>
+              <a:rPr lang="en-US" sz="1000" b="0" u="none" strike="noStrike">
+                <a:solidFill>
+                  <a:srgbClr val="8D99AE"/>
+                </a:solidFill>
+                <a:effectLst/>
+                <a:uFillTx/>
+                <a:latin typeface="Calibri"/>
+                <a:ea typeface="Calibri"/>
+              </a:rPr>
+              <a:t>2</a:t>
+            </a:r>
+            <a:r>
+              <a:rPr lang="en-US" sz="1000" b="0" u="none" strike="noStrike">
+                <a:solidFill>
+                  <a:srgbClr val="8D99AE"/>
+                </a:solidFill>
+                <a:effectLst/>
+                <a:uFillTx/>
+                <a:latin typeface="Calibri"/>
+                <a:ea typeface="Calibri"/>
+              </a:rPr>
+              <a:t>9</a:t>
+            </a:r>
+            <a:endParaRPr lang="en-US" sz="1000" b="0" u="none" strike="noStrike">
+              <a:solidFill>
+                <a:srgbClr val="FFFFFF"/>
+              </a:solidFill>
+              <a:effectLst/>
+              <a:uFillTx/>
+              <a:latin typeface="Arial"/>
+            </a:endParaRPr>
+          </a:p>
+        </p:txBody>
+      </p:sp>
+    </p:spTree>
+  </p:cSld>
+  <mc:AlternateContent>
+    <mc:Choice Requires="p14">
+      <p:transition spd="slow" p14:dur="2000"/>
+    </mc:Choice>
+    <mc:Fallback>
+      <p:transition spd="slow"/>
+    </mc:Fallback>
+  </mc:AlternateContent>
+</p:sld>
+</file>
+
+<file path=ppt/slides/slide31.xml><?xml version="1.0" encoding="utf-8"?>
 <p:sld xmlns:a="http://schemas.openxmlformats.org/drawingml/2006/main" xmlns:p="http://schemas.openxmlformats.org/presentationml/2006/main" xmlns:r="http://schemas.openxmlformats.org/officeDocument/2006/relationships" xmlns:p14="http://schemas.microsoft.com/office/powerpoint/2010/main" xmlns:p15="http://schemas.microsoft.com/office/powerpoint/2012/main" xmlns:mc="http://schemas.openxmlformats.org/markup-compatibility/2006">
   <p:cSld>
     <p:bg>

</xml_diff>